<commit_message>
fix(animation): restore click and wipe pptx export semantics
Signed-off-by: Jacobinwwey <jacob.hxx.cn@outlook.com>
</commit_message>
<xml_diff>
--- a/tests/output/pptx-test/03-wipe-directions.pptx
+++ b/tests/output/pptx-test/03-wipe-directions.pptx
@@ -167,7 +167,7 @@
                                   <p:strVal val="visible"/>
                                 </p:to>
                               </p:set>
-                              <p:animEffect transition="in">
+                              <p:animEffect transition="in" filter="wipe(right)">
                                 <p:cBhvr>
                                   <p:cTn id="6" dur="500" fill="hold"/>
                                   <p:tgtEl>
@@ -305,7 +305,7 @@
                                   <p:strVal val="visible"/>
                                 </p:to>
                               </p:set>
-                              <p:animEffect transition="in">
+                              <p:animEffect transition="in" filter="wipe(left)">
                                 <p:cBhvr>
                                   <p:cTn id="6" dur="500" fill="hold"/>
                                   <p:tgtEl>
@@ -443,7 +443,7 @@
                                   <p:strVal val="visible"/>
                                 </p:to>
                               </p:set>
-                              <p:animEffect transition="in">
+                              <p:animEffect transition="in" filter="wipe(down)">
                                 <p:cBhvr>
                                   <p:cTn id="6" dur="500" fill="hold"/>
                                   <p:tgtEl>
@@ -581,7 +581,7 @@
                                   <p:strVal val="visible"/>
                                 </p:to>
                               </p:set>
-                              <p:animEffect transition="in">
+                              <p:animEffect transition="in" filter="wipe(up)">
                                 <p:cBhvr>
                                   <p:cTn id="6" dur="500" fill="hold"/>
                                   <p:tgtEl>

</xml_diff>